<commit_message>
docs: update evaluation results for alpha=0.5 (avg_relevancy=0.857, source_accuracy=0.967)
Co-Authored-By: Claude Sonnet 4.6 <noreply@anthropic.com>
</commit_message>
<xml_diff>
--- a/Enterprise_HR_RAG_Platform.pptx
+++ b/Enterprise_HR_RAG_Platform.pptx
@@ -17776,7 +17776,7 @@
                             <a:srgbClr val="262626"/>
                           </a:solidFill>
                         </a:rPr>
-                        <a:t>0.863</a:t>
+                        <a:t>0.857</a:t>
                       </a:r>
                     </a:p>
                   </a:txBody>
@@ -17948,7 +17948,7 @@
                             <a:srgbClr val="262626"/>
                           </a:solidFill>
                         </a:rPr>
-                        <a:t>0.850</a:t>
+                        <a:t>0.860</a:t>
                       </a:r>
                     </a:p>
                   </a:txBody>
@@ -18034,7 +18034,7 @@
                             <a:srgbClr val="262626"/>
                           </a:solidFill>
                         </a:rPr>
-                        <a:t>0.910</a:t>
+                        <a:t>0.880</a:t>
                       </a:r>
                     </a:p>
                   </a:txBody>

</xml_diff>